<commit_message>
add judges QR to pptx
</commit_message>
<xml_diff>
--- a/PPTX_Files_Judging/0Q7eD1P.pptx
+++ b/PPTX_Files_Judging/0Q7eD1P.pptx
@@ -14187,6 +14187,30 @@
           </a:ln>
         </p:spPr>
       </p:cxnSp>
+      <p:pic>
+        <p:nvPicPr>
+          <p:cNvPr id="108" name="Picture 107" descr="47C.png"/>
+          <p:cNvPicPr>
+            <a:picLocks noChangeAspect="1"/>
+          </p:cNvPicPr>
+          <p:nvPr/>
+        </p:nvPicPr>
+        <p:blipFill>
+          <a:blip r:embed="rId5"/>
+          <a:stretch>
+            <a:fillRect/>
+          </a:stretch>
+        </p:blipFill>
+        <p:spPr>
+          <a:xfrm>
+            <a:off x="29279088" y="576072"/>
+            <a:ext cx="2103120" cy="3108960"/>
+          </a:xfrm>
+          <a:prstGeom prst="rect">
+            <a:avLst/>
+          </a:prstGeom>
+        </p:spPr>
+      </p:pic>
     </p:spTree>
   </p:cSld>
   <p:clrMapOvr>

</xml_diff>